<commit_message>
latest tdd with blazor changes
</commit_message>
<xml_diff>
--- a/2026-05-13-SDD-TDDWithBlazor/TDD with Blazor.pptx
+++ b/2026-05-13-SDD-TDDWithBlazor/TDD with Blazor.pptx
@@ -248,7 +248,7 @@
           <a:p>
             <a:fld id="{8EBF47D1-607F-45EE-AE63-C10CF3AC8DD9}" type="datetimeFigureOut">
               <a:rPr lang="en-US" smtClean="0"/>
-              <a:t>5/9/26</a:t>
+              <a:t>5/11/26</a:t>
             </a:fld>
             <a:endParaRPr lang="en-US"/>
           </a:p>
@@ -2491,7 +2491,73 @@
           <a:bodyPr/>
           <a:lstStyle/>
           <a:p>
+            <a:pPr marL="228600" indent="-228600">
+              <a:buAutoNum type="arabicPeriod"/>
+            </a:pPr>
+            <a:r>
+              <a:rPr lang="en-US"/>
+              <a:t>Command N = New File</a:t>
+            </a:r>
+          </a:p>
+          <a:p>
+            <a:pPr marL="228600" indent="-228600">
+              <a:buAutoNum type="arabicPeriod"/>
+            </a:pPr>
             <a:endParaRPr lang="en-US" dirty="0"/>
+          </a:p>
+          <a:p>
+            <a:pPr marL="228600" indent="-228600">
+              <a:buAutoNum type="arabicPeriod"/>
+            </a:pPr>
+            <a:r>
+              <a:rPr lang="en-US" dirty="0"/>
+              <a:t>Counter Demo</a:t>
+            </a:r>
+          </a:p>
+          <a:p>
+            <a:pPr marL="228600" indent="-228600">
+              <a:buAutoNum type="arabicPeriod"/>
+            </a:pPr>
+            <a:r>
+              <a:rPr lang="en-US" dirty="0"/>
+              <a:t>Start with failing test for current count is 0</a:t>
+            </a:r>
+          </a:p>
+          <a:p>
+            <a:pPr marL="228600" indent="-228600">
+              <a:buAutoNum type="arabicPeriod"/>
+            </a:pPr>
+            <a:r>
+              <a:rPr lang="en-US" dirty="0"/>
+              <a:t>Then make it pass hardcoding things</a:t>
+            </a:r>
+          </a:p>
+          <a:p>
+            <a:pPr marL="228600" indent="-228600">
+              <a:buAutoNum type="arabicPeriod"/>
+            </a:pPr>
+            <a:r>
+              <a:rPr lang="en-US" dirty="0"/>
+              <a:t>Then make a failing test for current count is 1 after you click the Increment button</a:t>
+            </a:r>
+          </a:p>
+          <a:p>
+            <a:pPr marL="228600" indent="-228600">
+              <a:buAutoNum type="arabicPeriod"/>
+            </a:pPr>
+            <a:r>
+              <a:rPr lang="en-US" dirty="0"/>
+              <a:t>Then make it pass</a:t>
+            </a:r>
+          </a:p>
+          <a:p>
+            <a:pPr marL="228600" indent="-228600">
+              <a:buAutoNum type="arabicPeriod"/>
+            </a:pPr>
+            <a:r>
+              <a:rPr lang="en-US" dirty="0"/>
+              <a:t>Refactor</a:t>
+            </a:r>
           </a:p>
         </p:txBody>
       </p:sp>
@@ -5131,7 +5197,7 @@
           <a:p>
             <a:fld id="{A4BF2526-C75C-47BE-928B-0135A92A66BE}" type="datetimeFigureOut">
               <a:rPr lang="en-US" smtClean="0"/>
-              <a:t>5/9/26</a:t>
+              <a:t>5/11/26</a:t>
             </a:fld>
             <a:endParaRPr lang="en-US"/>
           </a:p>
@@ -5329,7 +5395,7 @@
           <a:p>
             <a:fld id="{A4BF2526-C75C-47BE-928B-0135A92A66BE}" type="datetimeFigureOut">
               <a:rPr lang="en-US" smtClean="0"/>
-              <a:t>5/9/26</a:t>
+              <a:t>5/11/26</a:t>
             </a:fld>
             <a:endParaRPr lang="en-US"/>
           </a:p>
@@ -5537,7 +5603,7 @@
           <a:p>
             <a:fld id="{A4BF2526-C75C-47BE-928B-0135A92A66BE}" type="datetimeFigureOut">
               <a:rPr lang="en-US" smtClean="0"/>
-              <a:t>5/9/26</a:t>
+              <a:t>5/11/26</a:t>
             </a:fld>
             <a:endParaRPr lang="en-US"/>
           </a:p>
@@ -5735,7 +5801,7 @@
           <a:p>
             <a:fld id="{A4BF2526-C75C-47BE-928B-0135A92A66BE}" type="datetimeFigureOut">
               <a:rPr lang="en-US" smtClean="0"/>
-              <a:t>5/9/26</a:t>
+              <a:t>5/11/26</a:t>
             </a:fld>
             <a:endParaRPr lang="en-US"/>
           </a:p>
@@ -6010,7 +6076,7 @@
           <a:p>
             <a:fld id="{A4BF2526-C75C-47BE-928B-0135A92A66BE}" type="datetimeFigureOut">
               <a:rPr lang="en-US" smtClean="0"/>
-              <a:t>5/9/26</a:t>
+              <a:t>5/11/26</a:t>
             </a:fld>
             <a:endParaRPr lang="en-US"/>
           </a:p>
@@ -6275,7 +6341,7 @@
           <a:p>
             <a:fld id="{A4BF2526-C75C-47BE-928B-0135A92A66BE}" type="datetimeFigureOut">
               <a:rPr lang="en-US" smtClean="0"/>
-              <a:t>5/9/26</a:t>
+              <a:t>5/11/26</a:t>
             </a:fld>
             <a:endParaRPr lang="en-US"/>
           </a:p>
@@ -6687,7 +6753,7 @@
           <a:p>
             <a:fld id="{A4BF2526-C75C-47BE-928B-0135A92A66BE}" type="datetimeFigureOut">
               <a:rPr lang="en-US" smtClean="0"/>
-              <a:t>5/9/26</a:t>
+              <a:t>5/11/26</a:t>
             </a:fld>
             <a:endParaRPr lang="en-US"/>
           </a:p>
@@ -6828,7 +6894,7 @@
           <a:p>
             <a:fld id="{A4BF2526-C75C-47BE-928B-0135A92A66BE}" type="datetimeFigureOut">
               <a:rPr lang="en-US" smtClean="0"/>
-              <a:t>5/9/26</a:t>
+              <a:t>5/11/26</a:t>
             </a:fld>
             <a:endParaRPr lang="en-US"/>
           </a:p>
@@ -6941,7 +7007,7 @@
           <a:p>
             <a:fld id="{A4BF2526-C75C-47BE-928B-0135A92A66BE}" type="datetimeFigureOut">
               <a:rPr lang="en-US" smtClean="0"/>
-              <a:t>5/9/26</a:t>
+              <a:t>5/11/26</a:t>
             </a:fld>
             <a:endParaRPr lang="en-US"/>
           </a:p>
@@ -7252,7 +7318,7 @@
           <a:p>
             <a:fld id="{A4BF2526-C75C-47BE-928B-0135A92A66BE}" type="datetimeFigureOut">
               <a:rPr lang="en-US" smtClean="0"/>
-              <a:t>5/9/26</a:t>
+              <a:t>5/11/26</a:t>
             </a:fld>
             <a:endParaRPr lang="en-US"/>
           </a:p>
@@ -7540,7 +7606,7 @@
           <a:p>
             <a:fld id="{A4BF2526-C75C-47BE-928B-0135A92A66BE}" type="datetimeFigureOut">
               <a:rPr lang="en-US" smtClean="0"/>
-              <a:t>5/9/26</a:t>
+              <a:t>5/11/26</a:t>
             </a:fld>
             <a:endParaRPr lang="en-US"/>
           </a:p>
@@ -7781,7 +7847,7 @@
           <a:p>
             <a:fld id="{A4BF2526-C75C-47BE-928B-0135A92A66BE}" type="datetimeFigureOut">
               <a:rPr lang="en-US" smtClean="0"/>
-              <a:t>5/9/26</a:t>
+              <a:t>5/11/26</a:t>
             </a:fld>
             <a:endParaRPr lang="en-US"/>
           </a:p>

</xml_diff>